<commit_message>
exp17: FDR-control the human-atlas annotation confidence (gene-permutation null + BH)
Replace the heuristic specificity>0.12 gate with a proper permutation null: for each TF, reorder
its z-scored shift over genes (breaks gene<->signature alignment), recompute specificity; pool
draws across TFs (108,400) for a high-res shared null; per-TF p-value → Benjamini-Hochberg FDR.

Result (sobering): only 3 TFs at q<0.05 (2 at q<0.01), 89 at q<0.10 — the heuristic 73 is NOT
FDR-justified (172 collinear fetal types give a heavy null tail). per-TF perm_pval + fdr_qval now
in the annotation CSV; FDR + percentile-fallback counts in the stats JSON; deck slide-2 updated.

Co-Authored-By: Claude Opus 4.8 (1M context) <noreply@anthropic.com>
</commit_message>
<xml_diff>
--- a/slides/exp17_19_overview.pptx
+++ b/slides/exp17_19_overview.pptx
@@ -4243,8 +4243,8 @@
         </p:nvSpPr>
         <p:spPr>
           <a:xfrm>
-            <a:off x="6537960" y="3383280"/>
-            <a:ext cx="5212080" cy="2011680"/>
+            <a:off x="6537960" y="3291840"/>
+            <a:ext cx="5212080" cy="2194560"/>
           </a:xfrm>
           <a:prstGeom prst="rect">
             <a:avLst/>
@@ -4269,7 +4269,7 @@
               </a:defRPr>
             </a:pPr>
             <a:r>
-              <a:t>• TFs scored (n≥50 cells): 1084   |   cell types: 172</a:t>
+              <a:t>• TFs scored (n≥50): 1084  |  cell types: 172  |  shared genes: 6557</a:t>
             </a:r>
           </a:p>
           <a:p>
@@ -4285,7 +4285,7 @@
               </a:defRPr>
             </a:pPr>
             <a:r>
-              <a:t>• shared genes used: 6557  (discriminative half: 3278)</a:t>
+              <a:t>• cosine specificity: median 0.067, q90 0.109, max 0.394</a:t>
             </a:r>
           </a:p>
           <a:p>
@@ -4301,7 +4301,7 @@
               </a:defRPr>
             </a:pPr>
             <a:r>
-              <a:t>• cosine specificity: median 0.067, q90 0.109, max 0.394</a:t>
+              <a:t>• FDR-controlled (gene-permutation null, 108,400 draws + BH): q&lt;0.05 → 3 TFs, q&lt;0.10 → 89 TFs.</a:t>
             </a:r>
           </a:p>
           <a:p>
@@ -4317,7 +4317,7 @@
               </a:defRPr>
             </a:pPr>
             <a:r>
-              <a:t>• confidently annotated (spec&gt;0.12): 73 TFs  —  vs only 13 with the mouse MOCA reference.</a:t>
+              <a:t>• Heuristic spec&gt;0.12 flags 73 (vs 13 with mouse) — but only 3/89 survive FDR: 172 collinear types ⇒ heavy null tail.</a:t>
             </a:r>
           </a:p>
           <a:p>
@@ -4333,7 +4333,7 @@
               </a:defRPr>
             </a:pPr>
             <a:r>
-              <a:t>• cond(DᵀD)=1.1e+17 → collinear signatures, so unconstrained OLS/NNLS are ill-conditioned; cosine is the stable choice (README finding, re-confirmed).</a:t>
+              <a:t>• cond(DᵀD)=1e+17 ⇒ NNLS/OLS/ridge degenerate (0 calls); cosine is the stable method.</a:t>
             </a:r>
           </a:p>
         </p:txBody>
@@ -4407,7 +4407,7 @@
           <a:lstStyle/>
           <a:p>
             <a:pPr algn="l">
-              <a:defRPr sz="1300" b="0" i="0">
+              <a:defRPr sz="1250" b="0" i="0">
                 <a:solidFill>
                   <a:srgbClr val="1A1A2E"/>
                 </a:solidFill>
@@ -4415,7 +4415,7 @@
               </a:defRPr>
             </a:pPr>
             <a:r>
-              <a:t>Chosen: cosine alignment + specificity gate. The human reference is the same family the Joung paper used; the upgrade vs mouse is gene retention (no orthology loss) → more confident calls.</a:t>
+              <a:t>Chosen: cosine + permutation-FDR gate. Human ref (no orthology loss) gives far more candidate calls than mouse, but proper FDR shows the labels are still sparse → use the q&lt;0.10 / top-decile set as the confident pool, with care.</a:t>
             </a:r>
           </a:p>
         </p:txBody>

</xml_diff>

<commit_message>
deck: slide-2 method table → FDR columns (#q<0.05 / #q<0.10) instead of heuristic confidence gates
</commit_message>
<xml_diff>
--- a/slides/exp17_19_overview.pptx
+++ b/slides/exp17_19_overview.pptx
@@ -3660,7 +3660,7 @@
                         </a:defRPr>
                       </a:pPr>
                       <a:r>
-                        <a:t>#conf(&gt;0.12)</a:t>
+                        <a:t>#(q&lt;0.05)</a:t>
                       </a:r>
                     </a:p>
                   </a:txBody>
@@ -3684,7 +3684,7 @@
                         </a:defRPr>
                       </a:pPr>
                       <a:r>
-                        <a:t>#conf(&gt;0.05)</a:t>
+                        <a:t>#(q&lt;0.10)</a:t>
                       </a:r>
                     </a:p>
                   </a:txBody>
@@ -3782,7 +3782,7 @@
                         </a:defRPr>
                       </a:pPr>
                       <a:r>
-                        <a:t>73</a:t>
+                        <a:t>3</a:t>
                       </a:r>
                     </a:p>
                   </a:txBody>
@@ -3806,7 +3806,7 @@
                         </a:defRPr>
                       </a:pPr>
                       <a:r>
-                        <a:t>949</a:t>
+                        <a:t>89</a:t>
                       </a:r>
                     </a:p>
                   </a:txBody>
@@ -3904,7 +3904,7 @@
                         </a:defRPr>
                       </a:pPr>
                       <a:r>
-                        <a:t>0</a:t>
+                        <a:t>0†</a:t>
                       </a:r>
                     </a:p>
                   </a:txBody>
@@ -3928,7 +3928,7 @@
                         </a:defRPr>
                       </a:pPr>
                       <a:r>
-                        <a:t>0</a:t>
+                        <a:t>0†</a:t>
                       </a:r>
                     </a:p>
                   </a:txBody>
@@ -4026,7 +4026,7 @@
                         </a:defRPr>
                       </a:pPr>
                       <a:r>
-                        <a:t>0</a:t>
+                        <a:t>0†</a:t>
                       </a:r>
                     </a:p>
                   </a:txBody>
@@ -4050,7 +4050,7 @@
                         </a:defRPr>
                       </a:pPr>
                       <a:r>
-                        <a:t>0</a:t>
+                        <a:t>0†</a:t>
                       </a:r>
                     </a:p>
                   </a:txBody>
@@ -4148,7 +4148,7 @@
                         </a:defRPr>
                       </a:pPr>
                       <a:r>
-                        <a:t>0</a:t>
+                        <a:t>0†</a:t>
                       </a:r>
                     </a:p>
                   </a:txBody>
@@ -4172,7 +4172,7 @@
                         </a:defRPr>
                       </a:pPr>
                       <a:r>
-                        <a:t>0</a:t>
+                        <a:t>0†</a:t>
                       </a:r>
                     </a:p>
                   </a:txBody>
@@ -4238,6 +4238,42 @@
       <p:sp>
         <p:nvSpPr>
           <p:cNvPr id="11" name="TextBox 10"/>
+          <p:cNvSpPr txBox="1"/>
+          <p:nvPr/>
+        </p:nvSpPr>
+        <p:spPr>
+          <a:xfrm>
+            <a:off x="6537960" y="2852928"/>
+            <a:ext cx="5166360" cy="274320"/>
+          </a:xfrm>
+          <a:prstGeom prst="rect">
+            <a:avLst/>
+          </a:prstGeom>
+          <a:noFill/>
+        </p:spPr>
+        <p:txBody>
+          <a:bodyPr wrap="square">
+            <a:spAutoFit/>
+          </a:bodyPr>
+          <a:lstStyle/>
+          <a:p>
+            <a:pPr algn="l">
+              <a:defRPr sz="800" b="0" i="1">
+                <a:solidFill>
+                  <a:srgbClr val="666666"/>
+                </a:solidFill>
+                <a:latin typeface="Calibri"/>
+              </a:defRPr>
+            </a:pPr>
+            <a:r>
+              <a:t>† FDR run on cosine (chosen); nnls/ols/ridge at null floor → 0 at any FDR</a:t>
+            </a:r>
+          </a:p>
+        </p:txBody>
+      </p:sp>
+      <p:sp>
+        <p:nvSpPr>
+          <p:cNvPr id="12" name="TextBox 11"/>
           <p:cNvSpPr txBox="1"/>
           <p:nvPr/>
         </p:nvSpPr>
@@ -4340,7 +4376,7 @@
       </p:sp>
       <p:sp>
         <p:nvSpPr>
-          <p:cNvPr id="12" name="Rounded Rectangle 11"/>
+          <p:cNvPr id="13" name="Rounded Rectangle 12"/>
           <p:cNvSpPr/>
           <p:nvPr/>
         </p:nvSpPr>
@@ -4386,7 +4422,7 @@
       </p:sp>
       <p:sp>
         <p:nvSpPr>
-          <p:cNvPr id="13" name="TextBox 12"/>
+          <p:cNvPr id="14" name="TextBox 13"/>
           <p:cNvSpPr txBox="1"/>
           <p:nvPr/>
         </p:nvSpPr>

</xml_diff>